<commit_message>
Updated Slides for better understanding.
</commit_message>
<xml_diff>
--- a/Slides/L4_Git-and-GitHub.pptx
+++ b/Slides/L4_Git-and-GitHub.pptx
@@ -3890,7 +3890,12 @@
             <p:ph type="sldImg"/>
           </p:nvPr>
         </p:nvSpPr>
-        <p:spPr/>
+        <p:spPr>
+          <a:xfrm>
+            <a:off x="0" y="763588"/>
+            <a:ext cx="0" cy="0"/>
+          </a:xfrm>
+        </p:spPr>
       </p:sp>
       <p:sp>
         <p:nvSpPr>
@@ -3908,7 +3913,15 @@
           <a:lstStyle/>
           <a:p>
             <a:r>
-              <a:t>origin is just the conventional name for the default remote. The -u flag sets the default so that plain git push works from then on.</a:t>
+              <a:rPr dirty="0"/>
+              <a:t>origin is just the conventional name for the default remote. The -u flag sets the default so that plain </a:t>
+            </a:r>
+            <a:r>
+              <a:rPr dirty="0" err="1"/>
+              <a:t>git</a:t>
+            </a:r>
+            <a:r>
+              <a:t> push works from then on.</a:t>
             </a:r>
           </a:p>
         </p:txBody>
@@ -56021,7 +56034,7 @@
         <p:spPr>
           <a:xfrm>
             <a:off x="580041" y="1949942"/>
-            <a:ext cx="8135334" cy="5593858"/>
+            <a:ext cx="8135334" cy="2677656"/>
           </a:xfrm>
           <a:prstGeom prst="rect">
             <a:avLst/>
@@ -56035,15 +56048,58 @@
           <a:lstStyle/>
           <a:p>
             <a:r>
+              <a:rPr sz="2400" b="0" dirty="0">
+                <a:latin typeface="Cambria"/>
+              </a:rPr>
+              <a:t>Create an empty repository on github.com first, then:</a:t>
+            </a:r>
+          </a:p>
+          <a:p>
+            <a:r>
+              <a:rPr sz="2400" dirty="0">
+                <a:latin typeface="Cambria"/>
+              </a:rPr>
+              <a:t> </a:t>
+            </a:r>
+          </a:p>
+          <a:p>
+            <a:r>
+              <a:rPr sz="2400" b="0" dirty="0" err="1">
+                <a:latin typeface="Cambria"/>
+              </a:rPr>
+              <a:t>git</a:t>
+            </a:r>
+            <a:r>
+              <a:rPr sz="2400" b="0" dirty="0">
+                <a:latin typeface="Cambria"/>
+              </a:rPr>
+              <a:t> remote add </a:t>
+            </a:r>
+            <a:r>
               <a:rPr sz="2400" b="0">
                 <a:latin typeface="Cambria"/>
               </a:rPr>
-              <a:t>Create an empty repository on github.com first, then:</a:t>
-            </a:r>
-          </a:p>
-          <a:p>
-            <a:r>
-              <a:rPr sz="2400">
+              <a:t>origin </a:t>
+            </a:r>
+            <a:r>
+              <a:rPr lang="en-US" sz="2400" b="0" smtClean="0">
+                <a:latin typeface="Cambria"/>
+              </a:rPr>
+              <a:t>https://</a:t>
+            </a:r>
+            <a:r>
+              <a:rPr sz="2400" b="0" smtClean="0">
+                <a:latin typeface="Cambria"/>
+              </a:rPr>
+              <a:t>github.com:you/lab1.git</a:t>
+            </a:r>
+            <a:endParaRPr sz="2400" b="0" dirty="0">
+              <a:latin typeface="Cambria"/>
+            </a:endParaRPr>
+          </a:p>
+          <a:p>
+            <a:r>
+              <a:rPr sz="2400" dirty="0">
                 <a:latin typeface="Cambria"/>
               </a:rPr>
               <a:t> </a:t>
@@ -56051,15 +56107,21 @@
           </a:p>
           <a:p>
             <a:r>
-              <a:rPr sz="2400" b="0">
-                <a:latin typeface="Cambria"/>
-              </a:rPr>
-              <a:t>git remote add origin git@github.com:you/lab1.git</a:t>
-            </a:r>
-          </a:p>
-          <a:p>
-            <a:r>
-              <a:rPr sz="2400">
+              <a:rPr sz="2400" b="0" dirty="0" err="1">
+                <a:latin typeface="Cambria"/>
+              </a:rPr>
+              <a:t>git</a:t>
+            </a:r>
+            <a:r>
+              <a:rPr sz="2400" b="0" dirty="0">
+                <a:latin typeface="Cambria"/>
+              </a:rPr>
+              <a:t> branch -M main</a:t>
+            </a:r>
+          </a:p>
+          <a:p>
+            <a:r>
+              <a:rPr sz="2400" dirty="0">
                 <a:latin typeface="Cambria"/>
               </a:rPr>
               <a:t> </a:t>
@@ -56067,26 +56129,16 @@
           </a:p>
           <a:p>
             <a:r>
-              <a:rPr sz="2400" b="0">
-                <a:latin typeface="Cambria"/>
-              </a:rPr>
-              <a:t>git branch -M main</a:t>
-            </a:r>
-          </a:p>
-          <a:p>
-            <a:r>
-              <a:rPr sz="2400">
-                <a:latin typeface="Cambria"/>
-              </a:rPr>
-              <a:t> </a:t>
-            </a:r>
-          </a:p>
-          <a:p>
-            <a:r>
-              <a:rPr sz="2400" b="0">
-                <a:latin typeface="Cambria"/>
-              </a:rPr>
-              <a:t>git push -u origin main</a:t>
+              <a:rPr sz="2400" b="0" dirty="0" err="1">
+                <a:latin typeface="Cambria"/>
+              </a:rPr>
+              <a:t>git</a:t>
+            </a:r>
+            <a:r>
+              <a:rPr sz="2400" b="0" dirty="0">
+                <a:latin typeface="Cambria"/>
+              </a:rPr>
+              <a:t> push -u origin main</a:t>
             </a:r>
           </a:p>
         </p:txBody>

</xml_diff>